<commit_message>
Corregir anécdota del 0xFF: fue prevención por cálculo, no hallazgo de campo
La guía y las notas de la presentación decían "lo descubrimos porque sonaba
un clic fortísimo en las pruebas" — eso no ocurrió. Revisando el historial
de Git se confirma que 0xFF se usó como silencio μ-law desde la primera
versión del companding; el error de rellenar con 0x00 (que decodifica a
-32124, casi fondo de escala) se detectó por aritmética al escribir el
código, nunca llegó a fallar audible en un teléfono real.

Corregido en ambos documentos para que la historia sea la que realmente
pasó: detección matemática preventiva, no depuración de campo. El resto de
anécdotas del proyecto (el crash de audio vía logcat, los 11 s de latencia,
"se recuperó al silenciar el micrófono", los filtros amputando la voz, el
desfase de relojes) se verificaron contra la conversación y sí ocurrieron
tal como están descritas.

Co-Authored-By: Claude Fable 5 <noreply@anthropic.com>
</commit_message>
<xml_diff>
--- a/docs/Presentacion_Sustentacion_DSP_BT_Analyzer.pptx
+++ b/docs/Presentacion_Sustentacion_DSP_BT_Analyzer.pptx
@@ -1358,7 +1358,7 @@
           <a:lstStyle/>
           <a:p>
             <a:r>
-              <a:t>≈1.5 min. Camina las tres tarjetas de izquierda a derecha: muestreo, cuantización, compresión. La anécdota del 0xFF demuestra que el código es de ustedes: el relleno con ceros sonaba como un clic fortísimo.</a:t>
+              <a:t>≈1.5 min. Camina las tres tarjetas de izquierda a derecha: muestreo, cuantización, compresión. OJO: esto se detectó por cálculo al escribir el código, NO se escuchó fallar en una prueba. Si preguntan 'como lo notaron', la respuesta honesta es: revisando la aritmética antes de que sonara mal.</a:t>
             </a:r>
           </a:p>
         </p:txBody>
@@ -9873,7 +9873,7 @@
                 </a:solidFill>
                 <a:latin typeface="Segoe UI"/>
               </a:rPr>
-              <a:t>Dato curioso ganado a las malas: el silencio en μ-law es 0xFF. El byte 0x00 es un estallido a casi fondo de escala.</a:t>
+              <a:t>Detalle que delata el dominio del formato: el silencio en μ-law es 0xFF, no 0x00 — ese decodifica a casi fondo de escala.</a:t>
             </a:r>
           </a:p>
         </p:txBody>

</xml_diff>